<commit_message>
Final Week 4 submission with FastAPI and Streamlit deployment
</commit_message>
<xml_diff>
--- a/AI_Mental_Health_Presentation.pptx
+++ b/AI_Mental_Health_Presentation.pptx
@@ -467,7 +467,7 @@
           <a:p>
             <a:fld id="{5BCAD085-E8A6-8845-BD4E-CB4CCA059FC4}" type="datetimeFigureOut">
               <a:rPr lang="en-US" smtClean="0"/>
-              <a:t>5/25/2026</a:t>
+              <a:t>5/27/2026</a:t>
             </a:fld>
             <a:endParaRPr lang="en-US"/>
           </a:p>
@@ -791,7 +791,7 @@
           <a:p>
             <a:fld id="{5BCAD085-E8A6-8845-BD4E-CB4CCA059FC4}" type="datetimeFigureOut">
               <a:rPr lang="en-US" smtClean="0"/>
-              <a:t>5/25/2026</a:t>
+              <a:t>5/27/2026</a:t>
             </a:fld>
             <a:endParaRPr lang="en-US"/>
           </a:p>
@@ -1039,7 +1039,7 @@
           <a:p>
             <a:fld id="{5BCAD085-E8A6-8845-BD4E-CB4CCA059FC4}" type="datetimeFigureOut">
               <a:rPr lang="en-US" smtClean="0"/>
-              <a:t>5/25/2026</a:t>
+              <a:t>5/27/2026</a:t>
             </a:fld>
             <a:endParaRPr lang="en-US"/>
           </a:p>
@@ -1378,7 +1378,7 @@
           <a:p>
             <a:fld id="{5BCAD085-E8A6-8845-BD4E-CB4CCA059FC4}" type="datetimeFigureOut">
               <a:rPr lang="en-US" smtClean="0"/>
-              <a:t>5/25/2026</a:t>
+              <a:t>5/27/2026</a:t>
             </a:fld>
             <a:endParaRPr lang="en-US"/>
           </a:p>
@@ -1725,7 +1725,7 @@
           <a:p>
             <a:fld id="{5BCAD085-E8A6-8845-BD4E-CB4CCA059FC4}" type="datetimeFigureOut">
               <a:rPr lang="en-US" smtClean="0"/>
-              <a:t>5/25/2026</a:t>
+              <a:t>5/27/2026</a:t>
             </a:fld>
             <a:endParaRPr lang="en-US"/>
           </a:p>
@@ -2099,7 +2099,7 @@
           <a:p>
             <a:fld id="{5BCAD085-E8A6-8845-BD4E-CB4CCA059FC4}" type="datetimeFigureOut">
               <a:rPr lang="en-US" smtClean="0"/>
-              <a:t>5/25/2026</a:t>
+              <a:t>5/27/2026</a:t>
             </a:fld>
             <a:endParaRPr lang="en-US"/>
           </a:p>
@@ -2569,7 +2569,7 @@
           <a:p>
             <a:fld id="{5BCAD085-E8A6-8845-BD4E-CB4CCA059FC4}" type="datetimeFigureOut">
               <a:rPr lang="en-US" smtClean="0"/>
-              <a:t>5/25/2026</a:t>
+              <a:t>5/27/2026</a:t>
             </a:fld>
             <a:endParaRPr lang="en-US"/>
           </a:p>
@@ -2774,7 +2774,7 @@
           <a:p>
             <a:fld id="{5BCAD085-E8A6-8845-BD4E-CB4CCA059FC4}" type="datetimeFigureOut">
               <a:rPr lang="en-US" smtClean="0"/>
-              <a:t>5/25/2026</a:t>
+              <a:t>5/27/2026</a:t>
             </a:fld>
             <a:endParaRPr lang="en-US"/>
           </a:p>
@@ -2985,7 +2985,7 @@
           <a:p>
             <a:fld id="{5BCAD085-E8A6-8845-BD4E-CB4CCA059FC4}" type="datetimeFigureOut">
               <a:rPr lang="en-US" smtClean="0"/>
-              <a:t>5/25/2026</a:t>
+              <a:t>5/27/2026</a:t>
             </a:fld>
             <a:endParaRPr lang="en-US"/>
           </a:p>
@@ -3217,7 +3217,7 @@
           <a:p>
             <a:fld id="{5BCAD085-E8A6-8845-BD4E-CB4CCA059FC4}" type="datetimeFigureOut">
               <a:rPr lang="en-US" smtClean="0"/>
-              <a:t>5/25/2026</a:t>
+              <a:t>5/27/2026</a:t>
             </a:fld>
             <a:endParaRPr lang="en-US"/>
           </a:p>
@@ -3465,7 +3465,7 @@
           <a:p>
             <a:fld id="{5BCAD085-E8A6-8845-BD4E-CB4CCA059FC4}" type="datetimeFigureOut">
               <a:rPr lang="en-US" smtClean="0"/>
-              <a:t>5/25/2026</a:t>
+              <a:t>5/27/2026</a:t>
             </a:fld>
             <a:endParaRPr lang="en-US"/>
           </a:p>
@@ -3763,7 +3763,7 @@
           <a:p>
             <a:fld id="{5BCAD085-E8A6-8845-BD4E-CB4CCA059FC4}" type="datetimeFigureOut">
               <a:rPr lang="en-US" smtClean="0"/>
-              <a:t>5/25/2026</a:t>
+              <a:t>5/27/2026</a:t>
             </a:fld>
             <a:endParaRPr lang="en-US"/>
           </a:p>
@@ -4157,7 +4157,7 @@
           <a:p>
             <a:fld id="{5BCAD085-E8A6-8845-BD4E-CB4CCA059FC4}" type="datetimeFigureOut">
               <a:rPr lang="en-US" smtClean="0"/>
-              <a:t>5/25/2026</a:t>
+              <a:t>5/27/2026</a:t>
             </a:fld>
             <a:endParaRPr lang="en-US"/>
           </a:p>
@@ -4306,7 +4306,7 @@
           <a:p>
             <a:fld id="{5BCAD085-E8A6-8845-BD4E-CB4CCA059FC4}" type="datetimeFigureOut">
               <a:rPr lang="en-US" smtClean="0"/>
-              <a:t>5/25/2026</a:t>
+              <a:t>5/27/2026</a:t>
             </a:fld>
             <a:endParaRPr lang="en-US"/>
           </a:p>
@@ -4432,7 +4432,7 @@
           <a:p>
             <a:fld id="{5BCAD085-E8A6-8845-BD4E-CB4CCA059FC4}" type="datetimeFigureOut">
               <a:rPr lang="en-US" smtClean="0"/>
-              <a:t>5/25/2026</a:t>
+              <a:t>5/27/2026</a:t>
             </a:fld>
             <a:endParaRPr lang="en-US"/>
           </a:p>
@@ -4687,7 +4687,7 @@
           <a:p>
             <a:fld id="{5BCAD085-E8A6-8845-BD4E-CB4CCA059FC4}" type="datetimeFigureOut">
               <a:rPr lang="en-US" smtClean="0"/>
-              <a:t>5/25/2026</a:t>
+              <a:t>5/27/2026</a:t>
             </a:fld>
             <a:endParaRPr lang="en-US"/>
           </a:p>
@@ -5002,7 +5002,7 @@
           <a:p>
             <a:fld id="{5BCAD085-E8A6-8845-BD4E-CB4CCA059FC4}" type="datetimeFigureOut">
               <a:rPr lang="en-US" smtClean="0"/>
-              <a:t>5/25/2026</a:t>
+              <a:t>5/27/2026</a:t>
             </a:fld>
             <a:endParaRPr lang="en-US"/>
           </a:p>
@@ -5353,7 +5353,7 @@
           <a:p>
             <a:fld id="{5BCAD085-E8A6-8845-BD4E-CB4CCA059FC4}" type="datetimeFigureOut">
               <a:rPr lang="en-US" smtClean="0"/>
-              <a:t>5/25/2026</a:t>
+              <a:t>5/27/2026</a:t>
             </a:fld>
             <a:endParaRPr lang="en-US"/>
           </a:p>
@@ -5941,7 +5941,7 @@
         </p:spPr>
         <p:txBody>
           <a:bodyPr>
-            <a:normAutofit/>
+            <a:normAutofit lnSpcReduction="10000"/>
           </a:bodyPr>
           <a:lstStyle/>
           <a:p>
@@ -5961,6 +5961,16 @@
               </a:rPr>
               <a:t>AIML-4 Demo Walkthrough</a:t>
             </a:r>
+            <a:endParaRPr lang="en-IN" dirty="0">
+              <a:latin typeface="Times New Roman" panose="02020603050405020304" pitchFamily="18" charset="0"/>
+              <a:cs typeface="Times New Roman" panose="02020603050405020304" pitchFamily="18" charset="0"/>
+            </a:endParaRPr>
+          </a:p>
+          <a:p>
+            <a:endParaRPr dirty="0">
+              <a:latin typeface="Times New Roman" panose="02020603050405020304" pitchFamily="18" charset="0"/>
+              <a:cs typeface="Times New Roman" panose="02020603050405020304" pitchFamily="18" charset="0"/>
+            </a:endParaRPr>
           </a:p>
           <a:p>
             <a:r>

</xml_diff>